<commit_message>
A Point does not restrict what we measure any more
</commit_message>
<xml_diff>
--- a/docs/Thorium.pptx
+++ b/docs/Thorium.pptx
@@ -50849,7 +50849,7 @@
             </a:pPr>
             <a:r>
               <a:rPr lang="en-GB" dirty="0"/>
-              <a:t>Fifteen mistakes that now fail the build</a:t>
+              <a:t>Fourteen mistakes that now fail the build</a:t>
             </a:r>
           </a:p>
         </p:txBody>
@@ -50973,13 +50973,6 @@
             <a:r>
               <a:rPr lang="en-GB" dirty="0"/>
               <a:t>A misspelled test point</a:t>
-            </a:r>
-          </a:p>
-          <a:p>
-            <a:pPr/>
-            <a:r>
-              <a:rPr lang="en-GB" dirty="0"/>
-              <a:t>Current measured on a voltage point</a:t>
             </a:r>
           </a:p>
           <a:p>

</xml_diff>

<commit_message>
Catching unwired sense cables
</commit_message>
<xml_diff>
--- a/docs/Thorium.pptx
+++ b/docs/Thorium.pptx
@@ -50849,7 +50849,7 @@
             </a:pPr>
             <a:r>
               <a:rPr lang="en-GB" dirty="0"/>
-              <a:t>Fourteen mistakes that now fail the build</a:t>
+              <a:t>Fifteen mistakes that now fail the build</a:t>
             </a:r>
           </a:p>
         </p:txBody>
@@ -51052,6 +51052,13 @@
             <a:r>
               <a:rPr lang="en-GB" dirty="0"/>
               <a:t>A half-declared unit</a:t>
+            </a:r>
+          </a:p>
+          <a:p>
+            <a:pPr/>
+            <a:r>
+              <a:rPr lang="en-GB" dirty="0"/>
+              <a:t>Sense leads wired without force leads</a:t>
             </a:r>
           </a:p>
           <a:p>

</xml_diff>

<commit_message>
libs catalog renamed to framework
</commit_message>
<xml_diff>
--- a/docs/Thorium.pptx
+++ b/docs/Thorium.pptx
@@ -49549,11 +49549,11 @@
                   <a:srgbClr val="9795FF"/>
                 </a:solidFill>
               </a:rPr>
-              <a:t>libs/  </a:t>
+              <a:t>framework/  </a:t>
             </a:r>
             <a:r>
               <a:rPr lang="en-GB" dirty="0"/>
-              <a:t>the portable framework — units, criteria, the verbs, the journal</a:t>
+              <a:t>units, criteria, the verbs, the journal, the runner — portable</a:t>
             </a:r>
           </a:p>
           <a:p>
@@ -49609,7 +49609,7 @@
             </a:pPr>
             <a:r>
               <a:rPr lang="en-GB" dirty="0"/>
-              <a:t>It reuses libs/ untouched and brings its own three.</a:t>
+              <a:t>It reuses framework/ untouched and brings its own three.</a:t>
             </a:r>
           </a:p>
         </p:txBody>

</xml_diff>